<commit_message>
Time-machine graphic standardized: add to §2 '2016' divider + hook closing 'step into a time machine' (→1998); build editable PPTX for §2 (w/ time machine), §2b (2026), hook (7 slides); pptxlib embed_svg fixes (raw-svg casing, strip CSS style)
Co-Authored-By: Claude Opus 4.8 (1M context) <noreply@anthropic.com>
Claude-Session: https://claude.ai/code/session_0137U15CumPjTBBPfaV8DW99
</commit_message>
<xml_diff>
--- a/keynote-iwbi-2026/pptx/IWBI2026_Trivedi_00_hook.pptx
+++ b/keynote-iwbi-2026/pptx/IWBI2026_Trivedi_00_hook.pptx
@@ -11,6 +11,7 @@
     <p:sldId id="259" r:id="rId11"/>
     <p:sldId id="260" r:id="rId12"/>
     <p:sldId id="261" r:id="rId13"/>
+    <p:sldId id="262" r:id="rId14"/>
   </p:sldIdLst>
   <p:sldSz cx="12191695" cy="6858000" type="screen4x3"/>
   <p:notesSz cx="6858000" cy="9144000"/>
@@ -858,6 +859,76 @@
           <a:p>
             <a:r>
               <a:t>So over the next thirty minutes or so, I want to take you on a short journey of how we got here and where we can expect to go: from the lesion, to the image, to the patient. And I'll start with a cautionary tale, because this field has overpromised before.</a:t>
+            </a:r>
+          </a:p>
+        </p:txBody>
+      </p:sp>
+      <p:sp>
+        <p:nvSpPr>
+          <p:cNvPr id="4" name="Slide Number Placeholder 3"/>
+          <p:cNvSpPr>
+            <a:spLocks noGrp="1"/>
+          </p:cNvSpPr>
+          <p:nvPr>
+            <p:ph type="sldNum" idx="5" sz="quarter"/>
+          </p:nvPr>
+        </p:nvSpPr>
+        <p:spPr/>
+      </p:sp>
+    </p:spTree>
+  </p:cSld>
+  <p:clrMapOvr>
+    <a:masterClrMapping/>
+  </p:clrMapOvr>
+</p:notes>
+</file>
+
+<file path=ppt/notesSlides/notesSlide7.xml><?xml version="1.0" encoding="utf-8"?>
+<p:notes xmlns:a="http://schemas.openxmlformats.org/drawingml/2006/main" xmlns:p="http://schemas.openxmlformats.org/presentationml/2006/main" xmlns:r="http://schemas.openxmlformats.org/officeDocument/2006/relationships">
+  <p:cSld>
+    <p:spTree>
+      <p:nvGrpSpPr>
+        <p:cNvPr id="1" name=""/>
+        <p:cNvGrpSpPr/>
+        <p:nvPr/>
+      </p:nvGrpSpPr>
+      <p:grpSpPr>
+        <a:xfrm>
+          <a:off x="0" y="0"/>
+          <a:ext cx="0" cy="0"/>
+          <a:chOff x="0" y="0"/>
+          <a:chExt cx="0" cy="0"/>
+        </a:xfrm>
+      </p:grpSpPr>
+      <p:sp>
+        <p:nvSpPr>
+          <p:cNvPr id="2" name="Slide Image Placeholder 1"/>
+          <p:cNvSpPr>
+            <a:spLocks noGrp="1"/>
+          </p:cNvSpPr>
+          <p:nvPr>
+            <p:ph type="sldImg" idx="2"/>
+          </p:nvPr>
+        </p:nvSpPr>
+        <p:spPr/>
+      </p:sp>
+      <p:sp>
+        <p:nvSpPr>
+          <p:cNvPr id="3" name="Notes Placeholder 2"/>
+          <p:cNvSpPr>
+            <a:spLocks noGrp="1"/>
+          </p:cNvSpPr>
+          <p:nvPr>
+            <p:ph type="body" idx="3" sz="quarter"/>
+          </p:nvPr>
+        </p:nvSpPr>
+        <p:spPr/>
+        <p:txBody>
+          <a:bodyPr/>
+          <a:lstStyle/>
+          <a:p>
+            <a:r>
+              <a:t>To understand where this is going, we have to start with where it has been — because this field has overpromised before. So let's step into a time machine and go back to the beginning, to 1998.</a:t>
             </a:r>
           </a:p>
         </p:txBody>
@@ -3856,6 +3927,14 @@
 <file path=ppt/slides/slide1.xml><?xml version="1.0" encoding="utf-8"?>
 <p:sld xmlns:a="http://schemas.openxmlformats.org/drawingml/2006/main" xmlns:p="http://schemas.openxmlformats.org/presentationml/2006/main" xmlns:r="http://schemas.openxmlformats.org/officeDocument/2006/relationships">
   <p:cSld>
+    <p:bg>
+      <p:bgPr>
+        <a:solidFill>
+          <a:srgbClr val="0F141A"/>
+        </a:solidFill>
+        <a:effectLst/>
+      </p:bgPr>
+    </p:bg>
     <p:spTree>
       <p:nvGrpSpPr>
         <p:cNvPr id="1" name=""/>
@@ -3863,30 +3942,231 @@
         <p:nvPr/>
       </p:nvGrpSpPr>
       <p:grpSpPr/>
-      <p:pic>
-        <p:nvPicPr>
-          <p:cNvPr id="2" name="Picture 1" descr="hook_00.png"/>
-          <p:cNvPicPr>
-            <a:picLocks noChangeAspect="1"/>
-          </p:cNvPicPr>
+      <p:sp>
+        <p:nvSpPr>
+          <p:cNvPr id="2" name="Rectangle 1"/>
+          <p:cNvSpPr/>
           <p:nvPr/>
-        </p:nvPicPr>
-        <p:blipFill>
-          <a:blip r:embed="rId2"/>
-          <a:stretch>
-            <a:fillRect/>
-          </a:stretch>
-        </p:blipFill>
+        </p:nvSpPr>
         <p:spPr>
           <a:xfrm>
             <a:off x="0" y="0"/>
-            <a:ext cx="12191695" cy="6858000"/>
+            <a:ext cx="5486400" cy="38100"/>
           </a:xfrm>
           <a:prstGeom prst="rect">
             <a:avLst/>
           </a:prstGeom>
-        </p:spPr>
-      </p:pic>
+          <a:solidFill>
+            <a:srgbClr val="E7AC51"/>
+          </a:solidFill>
+          <a:ln>
+            <a:noFill/>
+          </a:ln>
+          <a:effectLst/>
+        </p:spPr>
+        <p:style>
+          <a:lnRef idx="1">
+            <a:schemeClr val="accent1"/>
+          </a:lnRef>
+          <a:fillRef idx="3">
+            <a:schemeClr val="accent1"/>
+          </a:fillRef>
+          <a:effectRef idx="2">
+            <a:schemeClr val="accent1"/>
+          </a:effectRef>
+          <a:fontRef idx="minor">
+            <a:schemeClr val="lt1"/>
+          </a:fontRef>
+        </p:style>
+        <p:txBody>
+          <a:bodyPr rtlCol="0" anchor="ctr"/>
+          <a:lstStyle/>
+          <a:p>
+            <a:pPr algn="ctr"/>
+          </a:p>
+        </p:txBody>
+      </p:sp>
+      <p:sp>
+        <p:nvSpPr>
+          <p:cNvPr id="3" name="TextBox 2"/>
+          <p:cNvSpPr txBox="1"/>
+          <p:nvPr/>
+        </p:nvSpPr>
+        <p:spPr>
+          <a:xfrm>
+            <a:off x="777240" y="868680"/>
+            <a:ext cx="10607040" cy="365760"/>
+          </a:xfrm>
+          <a:prstGeom prst="rect">
+            <a:avLst/>
+          </a:prstGeom>
+          <a:noFill/>
+        </p:spPr>
+        <p:txBody>
+          <a:bodyPr wrap="square" anchor="t" lIns="0" rIns="0" tIns="0" bIns="0">
+            <a:spAutoFit/>
+          </a:bodyPr>
+          <a:lstStyle/>
+          <a:p>
+            <a:pPr algn="l">
+              <a:lnSpc>
+                <a:spcPct val="100000"/>
+              </a:lnSpc>
+            </a:pPr>
+            <a:r>
+              <a:rPr sz="1200" b="1" i="0">
+                <a:solidFill>
+                  <a:srgbClr val="5FB7C9"/>
+                </a:solidFill>
+                <a:latin typeface="Consolas"/>
+              </a:rPr>
+              <a:t>International Workshop on Breast Imaging · 2026</a:t>
+            </a:r>
+          </a:p>
+        </p:txBody>
+      </p:sp>
+      <p:sp>
+        <p:nvSpPr>
+          <p:cNvPr id="4" name="TextBox 3"/>
+          <p:cNvSpPr txBox="1"/>
+          <p:nvPr/>
+        </p:nvSpPr>
+        <p:spPr>
+          <a:xfrm>
+            <a:off x="777240" y="2148840"/>
+            <a:ext cx="10607040" cy="2011680"/>
+          </a:xfrm>
+          <a:prstGeom prst="rect">
+            <a:avLst/>
+          </a:prstGeom>
+          <a:noFill/>
+        </p:spPr>
+        <p:txBody>
+          <a:bodyPr wrap="square" anchor="t" lIns="0" rIns="0" tIns="0" bIns="0">
+            <a:spAutoFit/>
+          </a:bodyPr>
+          <a:lstStyle/>
+          <a:p>
+            <a:pPr algn="l">
+              <a:lnSpc>
+                <a:spcPct val="98000"/>
+              </a:lnSpc>
+            </a:pPr>
+            <a:r>
+              <a:rPr sz="5400" b="1" i="0">
+                <a:solidFill>
+                  <a:srgbClr val="ECEFF3"/>
+                </a:solidFill>
+                <a:latin typeface="Arial"/>
+              </a:rPr>
+              <a:t>Thirty Years,</a:t>
+            </a:r>
+          </a:p>
+          <a:p>
+            <a:pPr algn="l">
+              <a:lnSpc>
+                <a:spcPct val="98000"/>
+              </a:lnSpc>
+            </a:pPr>
+            <a:r>
+              <a:rPr sz="5400" b="1" i="0">
+                <a:solidFill>
+                  <a:srgbClr val="E7AC51"/>
+                </a:solidFill>
+                <a:latin typeface="Arial"/>
+              </a:rPr>
+              <a:t>Three Eras.</a:t>
+            </a:r>
+          </a:p>
+        </p:txBody>
+      </p:sp>
+      <p:sp>
+        <p:nvSpPr>
+          <p:cNvPr id="5" name="TextBox 4"/>
+          <p:cNvSpPr txBox="1"/>
+          <p:nvPr/>
+        </p:nvSpPr>
+        <p:spPr>
+          <a:xfrm>
+            <a:off x="777240" y="4526280"/>
+            <a:ext cx="8686800" cy="822960"/>
+          </a:xfrm>
+          <a:prstGeom prst="rect">
+            <a:avLst/>
+          </a:prstGeom>
+          <a:noFill/>
+        </p:spPr>
+        <p:txBody>
+          <a:bodyPr wrap="square" anchor="t" lIns="0" rIns="0" tIns="0" bIns="0">
+            <a:spAutoFit/>
+          </a:bodyPr>
+          <a:lstStyle/>
+          <a:p>
+            <a:pPr algn="l">
+              <a:lnSpc>
+                <a:spcPct val="130000"/>
+              </a:lnSpc>
+            </a:pPr>
+            <a:r>
+              <a:rPr sz="2200" b="0" i="0">
+                <a:solidFill>
+                  <a:srgbClr val="9DA9B5"/>
+                </a:solidFill>
+                <a:latin typeface="Arial"/>
+              </a:rPr>
+              <a:t>AI in Breast Imaging — from CAD to Clinical Intelligence</a:t>
+            </a:r>
+          </a:p>
+        </p:txBody>
+      </p:sp>
+      <p:sp>
+        <p:nvSpPr>
+          <p:cNvPr id="6" name="TextBox 5"/>
+          <p:cNvSpPr txBox="1"/>
+          <p:nvPr/>
+        </p:nvSpPr>
+        <p:spPr>
+          <a:xfrm>
+            <a:off x="777240" y="5577840"/>
+            <a:ext cx="10607040" cy="457200"/>
+          </a:xfrm>
+          <a:prstGeom prst="rect">
+            <a:avLst/>
+          </a:prstGeom>
+          <a:noFill/>
+        </p:spPr>
+        <p:txBody>
+          <a:bodyPr wrap="square" anchor="t" lIns="0" rIns="0" tIns="0" bIns="0">
+            <a:spAutoFit/>
+          </a:bodyPr>
+          <a:lstStyle/>
+          <a:p>
+            <a:pPr algn="l">
+              <a:lnSpc>
+                <a:spcPct val="100000"/>
+              </a:lnSpc>
+            </a:pPr>
+            <a:r>
+              <a:rPr sz="1400" b="1" i="0">
+                <a:solidFill>
+                  <a:srgbClr val="ECEFF3"/>
+                </a:solidFill>
+                <a:latin typeface="Consolas"/>
+              </a:rPr>
+              <a:t>Hari Trivedi, MD</a:t>
+            </a:r>
+            <a:r>
+              <a:rPr sz="1400" b="0" i="0">
+                <a:solidFill>
+                  <a:srgbClr val="5C6975"/>
+                </a:solidFill>
+                <a:latin typeface="Consolas"/>
+              </a:rPr>
+              <a:t>  ·  Emory University</a:t>
+            </a:r>
+          </a:p>
+        </p:txBody>
+      </p:sp>
     </p:spTree>
   </p:cSld>
   <p:clrMapOvr>
@@ -3898,6 +4178,14 @@
 <file path=ppt/slides/slide2.xml><?xml version="1.0" encoding="utf-8"?>
 <p:sld xmlns:a="http://schemas.openxmlformats.org/drawingml/2006/main" xmlns:p="http://schemas.openxmlformats.org/presentationml/2006/main" xmlns:r="http://schemas.openxmlformats.org/officeDocument/2006/relationships">
   <p:cSld>
+    <p:bg>
+      <p:bgPr>
+        <a:solidFill>
+          <a:srgbClr val="0F141A"/>
+        </a:solidFill>
+        <a:effectLst/>
+      </p:bgPr>
+    </p:bg>
     <p:spTree>
       <p:nvGrpSpPr>
         <p:cNvPr id="1" name=""/>
@@ -3905,30 +4193,340 @@
         <p:nvPr/>
       </p:nvGrpSpPr>
       <p:grpSpPr/>
-      <p:pic>
-        <p:nvPicPr>
-          <p:cNvPr id="2" name="Picture 1" descr="hook_01.png"/>
-          <p:cNvPicPr>
-            <a:picLocks noChangeAspect="1"/>
-          </p:cNvPicPr>
+      <p:sp>
+        <p:nvSpPr>
+          <p:cNvPr id="2" name="Rectangle 1"/>
+          <p:cNvSpPr/>
           <p:nvPr/>
-        </p:nvPicPr>
-        <p:blipFill>
-          <a:blip r:embed="rId2"/>
-          <a:stretch>
-            <a:fillRect/>
-          </a:stretch>
-        </p:blipFill>
+        </p:nvSpPr>
         <p:spPr>
           <a:xfrm>
             <a:off x="0" y="0"/>
-            <a:ext cx="12191695" cy="6858000"/>
+            <a:ext cx="5486400" cy="38100"/>
           </a:xfrm>
           <a:prstGeom prst="rect">
             <a:avLst/>
           </a:prstGeom>
-        </p:spPr>
-      </p:pic>
+          <a:solidFill>
+            <a:srgbClr val="E7AC51"/>
+          </a:solidFill>
+          <a:ln>
+            <a:noFill/>
+          </a:ln>
+          <a:effectLst/>
+        </p:spPr>
+        <p:style>
+          <a:lnRef idx="1">
+            <a:schemeClr val="accent1"/>
+          </a:lnRef>
+          <a:fillRef idx="3">
+            <a:schemeClr val="accent1"/>
+          </a:fillRef>
+          <a:effectRef idx="2">
+            <a:schemeClr val="accent1"/>
+          </a:effectRef>
+          <a:fontRef idx="minor">
+            <a:schemeClr val="lt1"/>
+          </a:fontRef>
+        </p:style>
+        <p:txBody>
+          <a:bodyPr rtlCol="0" anchor="ctr"/>
+          <a:lstStyle/>
+          <a:p>
+            <a:pPr algn="ctr"/>
+          </a:p>
+        </p:txBody>
+      </p:sp>
+      <p:sp>
+        <p:nvSpPr>
+          <p:cNvPr id="3" name="Rounded Rectangle 2"/>
+          <p:cNvSpPr/>
+          <p:nvPr/>
+        </p:nvSpPr>
+        <p:spPr>
+          <a:xfrm>
+            <a:off x="777240" y="1051560"/>
+            <a:ext cx="3749039" cy="5029200"/>
+          </a:xfrm>
+          <a:prstGeom prst="roundRect">
+            <a:avLst/>
+          </a:prstGeom>
+          <a:solidFill>
+            <a:srgbClr val="06090C"/>
+          </a:solidFill>
+          <a:ln w="9525">
+            <a:solidFill>
+              <a:srgbClr val="C98A2E"/>
+            </a:solidFill>
+          </a:ln>
+          <a:effectLst/>
+        </p:spPr>
+        <p:style>
+          <a:lnRef idx="1">
+            <a:schemeClr val="accent1"/>
+          </a:lnRef>
+          <a:fillRef idx="3">
+            <a:schemeClr val="accent1"/>
+          </a:fillRef>
+          <a:effectRef idx="2">
+            <a:schemeClr val="accent1"/>
+          </a:effectRef>
+          <a:fontRef idx="minor">
+            <a:schemeClr val="lt1"/>
+          </a:fontRef>
+        </p:style>
+        <p:txBody>
+          <a:bodyPr rtlCol="0" anchor="ctr"/>
+          <a:lstStyle/>
+          <a:p>
+            <a:pPr algn="ctr"/>
+          </a:p>
+        </p:txBody>
+      </p:sp>
+      <p:sp>
+        <p:nvSpPr>
+          <p:cNvPr id="4" name="TextBox 3"/>
+          <p:cNvSpPr txBox="1"/>
+          <p:nvPr/>
+        </p:nvSpPr>
+        <p:spPr>
+          <a:xfrm>
+            <a:off x="886968" y="1106424"/>
+            <a:ext cx="3529583" cy="256032"/>
+          </a:xfrm>
+          <a:prstGeom prst="rect">
+            <a:avLst/>
+          </a:prstGeom>
+          <a:noFill/>
+        </p:spPr>
+        <p:txBody>
+          <a:bodyPr wrap="square" anchor="ctr" lIns="0" rIns="0" tIns="0" bIns="0">
+            <a:spAutoFit/>
+          </a:bodyPr>
+          <a:lstStyle/>
+          <a:p>
+            <a:pPr algn="l">
+              <a:lnSpc>
+                <a:spcPct val="100000"/>
+              </a:lnSpc>
+            </a:pPr>
+            <a:r>
+              <a:rPr sz="900" b="0" i="0">
+                <a:solidFill>
+                  <a:srgbClr val="9DA9B5"/>
+                </a:solidFill>
+                <a:latin typeface="Consolas"/>
+              </a:rPr>
+              <a:t>R MLO · screening</a:t>
+            </a:r>
+          </a:p>
+        </p:txBody>
+      </p:sp>
+      <p:sp>
+        <p:nvSpPr>
+          <p:cNvPr id="5" name="TextBox 4"/>
+          <p:cNvSpPr txBox="1"/>
+          <p:nvPr/>
+        </p:nvSpPr>
+        <p:spPr>
+          <a:xfrm>
+            <a:off x="886968" y="1106424"/>
+            <a:ext cx="3529583" cy="256032"/>
+          </a:xfrm>
+          <a:prstGeom prst="rect">
+            <a:avLst/>
+          </a:prstGeom>
+          <a:noFill/>
+        </p:spPr>
+        <p:txBody>
+          <a:bodyPr wrap="square" anchor="ctr" lIns="0" rIns="0" tIns="0" bIns="0">
+            <a:spAutoFit/>
+          </a:bodyPr>
+          <a:lstStyle/>
+          <a:p>
+            <a:pPr algn="r">
+              <a:lnSpc>
+                <a:spcPct val="100000"/>
+              </a:lnSpc>
+            </a:pPr>
+            <a:r>
+              <a:rPr sz="900" b="0" i="0">
+                <a:solidFill>
+                  <a:srgbClr val="5FB7C9"/>
+                </a:solidFill>
+                <a:latin typeface="Consolas"/>
+              </a:rPr>
+              <a:t>AI —</a:t>
+            </a:r>
+          </a:p>
+        </p:txBody>
+      </p:sp>
+      <p:sp>
+        <p:nvSpPr>
+          <p:cNvPr id="6" name="Rectangle 5"/>
+          <p:cNvSpPr/>
+          <p:nvPr/>
+        </p:nvSpPr>
+        <p:spPr>
+          <a:xfrm>
+            <a:off x="850392" y="1435607"/>
+            <a:ext cx="3602735" cy="12700"/>
+          </a:xfrm>
+          <a:prstGeom prst="rect">
+            <a:avLst/>
+          </a:prstGeom>
+          <a:solidFill>
+            <a:srgbClr val="2A333D"/>
+          </a:solidFill>
+          <a:ln>
+            <a:noFill/>
+          </a:ln>
+          <a:effectLst/>
+        </p:spPr>
+        <p:style>
+          <a:lnRef idx="1">
+            <a:schemeClr val="accent1"/>
+          </a:lnRef>
+          <a:fillRef idx="3">
+            <a:schemeClr val="accent1"/>
+          </a:fillRef>
+          <a:effectRef idx="2">
+            <a:schemeClr val="accent1"/>
+          </a:effectRef>
+          <a:fontRef idx="minor">
+            <a:schemeClr val="lt1"/>
+          </a:fontRef>
+        </p:style>
+        <p:txBody>
+          <a:bodyPr rtlCol="0" anchor="ctr"/>
+          <a:lstStyle/>
+          <a:p>
+            <a:pPr algn="ctr"/>
+          </a:p>
+        </p:txBody>
+      </p:sp>
+      <p:sp>
+        <p:nvSpPr>
+          <p:cNvPr id="7" name="Rectangle 6"/>
+          <p:cNvSpPr/>
+          <p:nvPr/>
+        </p:nvSpPr>
+        <p:spPr>
+          <a:xfrm>
+            <a:off x="886968" y="1527048"/>
+            <a:ext cx="3529583" cy="4425696"/>
+          </a:xfrm>
+          <a:prstGeom prst="rect">
+            <a:avLst/>
+          </a:prstGeom>
+          <a:solidFill>
+            <a:srgbClr val="000000"/>
+          </a:solidFill>
+          <a:ln>
+            <a:noFill/>
+          </a:ln>
+          <a:effectLst/>
+        </p:spPr>
+        <p:style>
+          <a:lnRef idx="1">
+            <a:schemeClr val="accent1"/>
+          </a:lnRef>
+          <a:fillRef idx="3">
+            <a:schemeClr val="accent1"/>
+          </a:fillRef>
+          <a:effectRef idx="2">
+            <a:schemeClr val="accent1"/>
+          </a:effectRef>
+          <a:fontRef idx="minor">
+            <a:schemeClr val="lt1"/>
+          </a:fontRef>
+        </p:style>
+        <p:txBody>
+          <a:bodyPr rtlCol="0" anchor="ctr"/>
+          <a:lstStyle/>
+          <a:p>
+            <a:pPr algn="ctr"/>
+          </a:p>
+        </p:txBody>
+      </p:sp>
+      <p:sp>
+        <p:nvSpPr>
+          <p:cNvPr id="8" name="TextBox 7"/>
+          <p:cNvSpPr txBox="1"/>
+          <p:nvPr/>
+        </p:nvSpPr>
+        <p:spPr>
+          <a:xfrm>
+            <a:off x="941832" y="5696712"/>
+            <a:ext cx="3419856" cy="274320"/>
+          </a:xfrm>
+          <a:prstGeom prst="rect">
+            <a:avLst/>
+          </a:prstGeom>
+          <a:noFill/>
+        </p:spPr>
+        <p:txBody>
+          <a:bodyPr wrap="square" anchor="t" lIns="0" rIns="0" tIns="0" bIns="0">
+            <a:spAutoFit/>
+          </a:bodyPr>
+          <a:lstStyle/>
+          <a:p>
+            <a:pPr algn="l">
+              <a:lnSpc>
+                <a:spcPct val="100000"/>
+              </a:lnSpc>
+            </a:pPr>
+            <a:r>
+              <a:rPr sz="800" b="0" i="0">
+                <a:solidFill>
+                  <a:srgbClr val="5C6975"/>
+                </a:solidFill>
+                <a:latin typeface="Consolas"/>
+              </a:rPr>
+              <a:t>[ de-identified Emory screening case ]</a:t>
+            </a:r>
+          </a:p>
+        </p:txBody>
+      </p:sp>
+      <p:sp>
+        <p:nvSpPr>
+          <p:cNvPr id="9" name="TextBox 8"/>
+          <p:cNvSpPr txBox="1"/>
+          <p:nvPr/>
+        </p:nvSpPr>
+        <p:spPr>
+          <a:xfrm>
+            <a:off x="5074920" y="2377440"/>
+            <a:ext cx="6400800" cy="2194560"/>
+          </a:xfrm>
+          <a:prstGeom prst="rect">
+            <a:avLst/>
+          </a:prstGeom>
+          <a:noFill/>
+        </p:spPr>
+        <p:txBody>
+          <a:bodyPr wrap="square" anchor="t" lIns="0" rIns="0" tIns="0" bIns="0">
+            <a:spAutoFit/>
+          </a:bodyPr>
+          <a:lstStyle/>
+          <a:p>
+            <a:pPr algn="l">
+              <a:lnSpc>
+                <a:spcPct val="110000"/>
+              </a:lnSpc>
+            </a:pPr>
+            <a:r>
+              <a:rPr sz="3400" b="1" i="0">
+                <a:solidFill>
+                  <a:srgbClr val="ECEFF3"/>
+                </a:solidFill>
+                <a:latin typeface="Arial"/>
+              </a:rPr>
+              <a:t>A normal screening mammogram — read as normal.</a:t>
+            </a:r>
+          </a:p>
+        </p:txBody>
+      </p:sp>
     </p:spTree>
   </p:cSld>
   <p:clrMapOvr>
@@ -3940,6 +4538,14 @@
 <file path=ppt/slides/slide3.xml><?xml version="1.0" encoding="utf-8"?>
 <p:sld xmlns:a="http://schemas.openxmlformats.org/drawingml/2006/main" xmlns:p="http://schemas.openxmlformats.org/presentationml/2006/main" xmlns:r="http://schemas.openxmlformats.org/officeDocument/2006/relationships">
   <p:cSld>
+    <p:bg>
+      <p:bgPr>
+        <a:solidFill>
+          <a:srgbClr val="0F141A"/>
+        </a:solidFill>
+        <a:effectLst/>
+      </p:bgPr>
+    </p:bg>
     <p:spTree>
       <p:nvGrpSpPr>
         <p:cNvPr id="1" name=""/>
@@ -3947,30 +4553,98 @@
         <p:nvPr/>
       </p:nvGrpSpPr>
       <p:grpSpPr/>
-      <p:pic>
-        <p:nvPicPr>
-          <p:cNvPr id="2" name="Picture 1" descr="hook_02.png"/>
-          <p:cNvPicPr>
-            <a:picLocks noChangeAspect="1"/>
-          </p:cNvPicPr>
+      <p:sp>
+        <p:nvSpPr>
+          <p:cNvPr id="2" name="Rectangle 1"/>
+          <p:cNvSpPr/>
           <p:nvPr/>
-        </p:nvPicPr>
-        <p:blipFill>
-          <a:blip r:embed="rId2"/>
-          <a:stretch>
-            <a:fillRect/>
-          </a:stretch>
-        </p:blipFill>
+        </p:nvSpPr>
         <p:spPr>
           <a:xfrm>
             <a:off x="0" y="0"/>
-            <a:ext cx="12191695" cy="6858000"/>
+            <a:ext cx="5486400" cy="38100"/>
           </a:xfrm>
           <a:prstGeom prst="rect">
             <a:avLst/>
           </a:prstGeom>
-        </p:spPr>
-      </p:pic>
+          <a:solidFill>
+            <a:srgbClr val="E7AC51"/>
+          </a:solidFill>
+          <a:ln>
+            <a:noFill/>
+          </a:ln>
+          <a:effectLst/>
+        </p:spPr>
+        <p:style>
+          <a:lnRef idx="1">
+            <a:schemeClr val="accent1"/>
+          </a:lnRef>
+          <a:fillRef idx="3">
+            <a:schemeClr val="accent1"/>
+          </a:fillRef>
+          <a:effectRef idx="2">
+            <a:schemeClr val="accent1"/>
+          </a:effectRef>
+          <a:fontRef idx="minor">
+            <a:schemeClr val="lt1"/>
+          </a:fontRef>
+        </p:style>
+        <p:txBody>
+          <a:bodyPr rtlCol="0" anchor="ctr"/>
+          <a:lstStyle/>
+          <a:p>
+            <a:pPr algn="ctr"/>
+          </a:p>
+        </p:txBody>
+      </p:sp>
+      <p:sp>
+        <p:nvSpPr>
+          <p:cNvPr id="3" name="TextBox 2"/>
+          <p:cNvSpPr txBox="1"/>
+          <p:nvPr/>
+        </p:nvSpPr>
+        <p:spPr>
+          <a:xfrm>
+            <a:off x="777240" y="2194560"/>
+            <a:ext cx="10058400" cy="2377440"/>
+          </a:xfrm>
+          <a:prstGeom prst="rect">
+            <a:avLst/>
+          </a:prstGeom>
+          <a:noFill/>
+        </p:spPr>
+        <p:txBody>
+          <a:bodyPr wrap="square" anchor="ctr" lIns="0" rIns="0" tIns="0" bIns="0">
+            <a:spAutoFit/>
+          </a:bodyPr>
+          <a:lstStyle/>
+          <a:p>
+            <a:pPr algn="l">
+              <a:lnSpc>
+                <a:spcPct val="105000"/>
+              </a:lnSpc>
+            </a:pPr>
+            <a:r>
+              <a:rPr sz="5600" b="1" i="0">
+                <a:solidFill>
+                  <a:srgbClr val="ECEFF3"/>
+                </a:solidFill>
+                <a:latin typeface="Arial"/>
+              </a:rPr>
+              <a:t>What are we </a:t>
+            </a:r>
+            <a:r>
+              <a:rPr sz="5600" b="1" i="0">
+                <a:solidFill>
+                  <a:srgbClr val="E7AC51"/>
+                </a:solidFill>
+                <a:latin typeface="Arial"/>
+              </a:rPr>
+              <a:t>not seeing?</a:t>
+            </a:r>
+          </a:p>
+        </p:txBody>
+      </p:sp>
     </p:spTree>
   </p:cSld>
   <p:clrMapOvr>
@@ -3982,6 +4656,14 @@
 <file path=ppt/slides/slide4.xml><?xml version="1.0" encoding="utf-8"?>
 <p:sld xmlns:a="http://schemas.openxmlformats.org/drawingml/2006/main" xmlns:p="http://schemas.openxmlformats.org/presentationml/2006/main" xmlns:r="http://schemas.openxmlformats.org/officeDocument/2006/relationships">
   <p:cSld>
+    <p:bg>
+      <p:bgPr>
+        <a:solidFill>
+          <a:srgbClr val="0F141A"/>
+        </a:solidFill>
+        <a:effectLst/>
+      </p:bgPr>
+    </p:bg>
     <p:spTree>
       <p:nvGrpSpPr>
         <p:cNvPr id="1" name=""/>
@@ -3989,30 +4671,807 @@
         <p:nvPr/>
       </p:nvGrpSpPr>
       <p:grpSpPr/>
-      <p:pic>
-        <p:nvPicPr>
-          <p:cNvPr id="2" name="Picture 1" descr="hook_03.png"/>
-          <p:cNvPicPr>
-            <a:picLocks noChangeAspect="1"/>
-          </p:cNvPicPr>
+      <p:sp>
+        <p:nvSpPr>
+          <p:cNvPr id="2" name="Rectangle 1"/>
+          <p:cNvSpPr/>
           <p:nvPr/>
-        </p:nvPicPr>
-        <p:blipFill>
-          <a:blip r:embed="rId2"/>
-          <a:stretch>
-            <a:fillRect/>
-          </a:stretch>
-        </p:blipFill>
+        </p:nvSpPr>
         <p:spPr>
           <a:xfrm>
             <a:off x="0" y="0"/>
-            <a:ext cx="12191695" cy="6858000"/>
+            <a:ext cx="5486400" cy="38100"/>
           </a:xfrm>
           <a:prstGeom prst="rect">
             <a:avLst/>
           </a:prstGeom>
-        </p:spPr>
-      </p:pic>
+          <a:solidFill>
+            <a:srgbClr val="E7AC51"/>
+          </a:solidFill>
+          <a:ln>
+            <a:noFill/>
+          </a:ln>
+          <a:effectLst/>
+        </p:spPr>
+        <p:style>
+          <a:lnRef idx="1">
+            <a:schemeClr val="accent1"/>
+          </a:lnRef>
+          <a:fillRef idx="3">
+            <a:schemeClr val="accent1"/>
+          </a:fillRef>
+          <a:effectRef idx="2">
+            <a:schemeClr val="accent1"/>
+          </a:effectRef>
+          <a:fontRef idx="minor">
+            <a:schemeClr val="lt1"/>
+          </a:fontRef>
+        </p:style>
+        <p:txBody>
+          <a:bodyPr rtlCol="0" anchor="ctr"/>
+          <a:lstStyle/>
+          <a:p>
+            <a:pPr algn="ctr"/>
+          </a:p>
+        </p:txBody>
+      </p:sp>
+      <p:sp>
+        <p:nvSpPr>
+          <p:cNvPr id="3" name="Rounded Rectangle 2"/>
+          <p:cNvSpPr/>
+          <p:nvPr/>
+        </p:nvSpPr>
+        <p:spPr>
+          <a:xfrm>
+            <a:off x="777240" y="914400"/>
+            <a:ext cx="3246120" cy="5120640"/>
+          </a:xfrm>
+          <a:prstGeom prst="roundRect">
+            <a:avLst/>
+          </a:prstGeom>
+          <a:solidFill>
+            <a:srgbClr val="06090C"/>
+          </a:solidFill>
+          <a:ln w="9525">
+            <a:solidFill>
+              <a:srgbClr val="C98A2E"/>
+            </a:solidFill>
+          </a:ln>
+          <a:effectLst/>
+        </p:spPr>
+        <p:style>
+          <a:lnRef idx="1">
+            <a:schemeClr val="accent1"/>
+          </a:lnRef>
+          <a:fillRef idx="3">
+            <a:schemeClr val="accent1"/>
+          </a:fillRef>
+          <a:effectRef idx="2">
+            <a:schemeClr val="accent1"/>
+          </a:effectRef>
+          <a:fontRef idx="minor">
+            <a:schemeClr val="lt1"/>
+          </a:fontRef>
+        </p:style>
+        <p:txBody>
+          <a:bodyPr rtlCol="0" anchor="ctr"/>
+          <a:lstStyle/>
+          <a:p>
+            <a:pPr algn="ctr"/>
+          </a:p>
+        </p:txBody>
+      </p:sp>
+      <p:sp>
+        <p:nvSpPr>
+          <p:cNvPr id="4" name="TextBox 3"/>
+          <p:cNvSpPr txBox="1"/>
+          <p:nvPr/>
+        </p:nvSpPr>
+        <p:spPr>
+          <a:xfrm>
+            <a:off x="886968" y="969264"/>
+            <a:ext cx="3026663" cy="256032"/>
+          </a:xfrm>
+          <a:prstGeom prst="rect">
+            <a:avLst/>
+          </a:prstGeom>
+          <a:noFill/>
+        </p:spPr>
+        <p:txBody>
+          <a:bodyPr wrap="square" anchor="ctr" lIns="0" rIns="0" tIns="0" bIns="0">
+            <a:spAutoFit/>
+          </a:bodyPr>
+          <a:lstStyle/>
+          <a:p>
+            <a:pPr algn="l">
+              <a:lnSpc>
+                <a:spcPct val="100000"/>
+              </a:lnSpc>
+            </a:pPr>
+            <a:r>
+              <a:rPr sz="900" b="0" i="0">
+                <a:solidFill>
+                  <a:srgbClr val="9DA9B5"/>
+                </a:solidFill>
+                <a:latin typeface="Consolas"/>
+              </a:rPr>
+              <a:t>R MLO · screening</a:t>
+            </a:r>
+          </a:p>
+        </p:txBody>
+      </p:sp>
+      <p:sp>
+        <p:nvSpPr>
+          <p:cNvPr id="5" name="TextBox 4"/>
+          <p:cNvSpPr txBox="1"/>
+          <p:nvPr/>
+        </p:nvSpPr>
+        <p:spPr>
+          <a:xfrm>
+            <a:off x="886968" y="969264"/>
+            <a:ext cx="3026663" cy="256032"/>
+          </a:xfrm>
+          <a:prstGeom prst="rect">
+            <a:avLst/>
+          </a:prstGeom>
+          <a:noFill/>
+        </p:spPr>
+        <p:txBody>
+          <a:bodyPr wrap="square" anchor="ctr" lIns="0" rIns="0" tIns="0" bIns="0">
+            <a:spAutoFit/>
+          </a:bodyPr>
+          <a:lstStyle/>
+          <a:p>
+            <a:pPr algn="r">
+              <a:lnSpc>
+                <a:spcPct val="100000"/>
+              </a:lnSpc>
+            </a:pPr>
+            <a:r>
+              <a:rPr sz="900" b="0" i="0">
+                <a:solidFill>
+                  <a:srgbClr val="5FB7C9"/>
+                </a:solidFill>
+                <a:latin typeface="Consolas"/>
+              </a:rPr>
+              <a:t>AI ✓✓✓</a:t>
+            </a:r>
+          </a:p>
+        </p:txBody>
+      </p:sp>
+      <p:sp>
+        <p:nvSpPr>
+          <p:cNvPr id="6" name="Rectangle 5"/>
+          <p:cNvSpPr/>
+          <p:nvPr/>
+        </p:nvSpPr>
+        <p:spPr>
+          <a:xfrm>
+            <a:off x="850392" y="1298448"/>
+            <a:ext cx="3099815" cy="12700"/>
+          </a:xfrm>
+          <a:prstGeom prst="rect">
+            <a:avLst/>
+          </a:prstGeom>
+          <a:solidFill>
+            <a:srgbClr val="2A333D"/>
+          </a:solidFill>
+          <a:ln>
+            <a:noFill/>
+          </a:ln>
+          <a:effectLst/>
+        </p:spPr>
+        <p:style>
+          <a:lnRef idx="1">
+            <a:schemeClr val="accent1"/>
+          </a:lnRef>
+          <a:fillRef idx="3">
+            <a:schemeClr val="accent1"/>
+          </a:fillRef>
+          <a:effectRef idx="2">
+            <a:schemeClr val="accent1"/>
+          </a:effectRef>
+          <a:fontRef idx="minor">
+            <a:schemeClr val="lt1"/>
+          </a:fontRef>
+        </p:style>
+        <p:txBody>
+          <a:bodyPr rtlCol="0" anchor="ctr"/>
+          <a:lstStyle/>
+          <a:p>
+            <a:pPr algn="ctr"/>
+          </a:p>
+        </p:txBody>
+      </p:sp>
+      <p:sp>
+        <p:nvSpPr>
+          <p:cNvPr id="7" name="Rectangle 6"/>
+          <p:cNvSpPr/>
+          <p:nvPr/>
+        </p:nvSpPr>
+        <p:spPr>
+          <a:xfrm>
+            <a:off x="886968" y="1389888"/>
+            <a:ext cx="3026663" cy="4517136"/>
+          </a:xfrm>
+          <a:prstGeom prst="rect">
+            <a:avLst/>
+          </a:prstGeom>
+          <a:solidFill>
+            <a:srgbClr val="000000"/>
+          </a:solidFill>
+          <a:ln>
+            <a:noFill/>
+          </a:ln>
+          <a:effectLst/>
+        </p:spPr>
+        <p:style>
+          <a:lnRef idx="1">
+            <a:schemeClr val="accent1"/>
+          </a:lnRef>
+          <a:fillRef idx="3">
+            <a:schemeClr val="accent1"/>
+          </a:fillRef>
+          <a:effectRef idx="2">
+            <a:schemeClr val="accent1"/>
+          </a:effectRef>
+          <a:fontRef idx="minor">
+            <a:schemeClr val="lt1"/>
+          </a:fontRef>
+        </p:style>
+        <p:txBody>
+          <a:bodyPr rtlCol="0" anchor="ctr"/>
+          <a:lstStyle/>
+          <a:p>
+            <a:pPr algn="ctr"/>
+          </a:p>
+        </p:txBody>
+      </p:sp>
+      <p:sp>
+        <p:nvSpPr>
+          <p:cNvPr id="8" name="TextBox 7"/>
+          <p:cNvSpPr txBox="1"/>
+          <p:nvPr/>
+        </p:nvSpPr>
+        <p:spPr>
+          <a:xfrm>
+            <a:off x="941832" y="5650992"/>
+            <a:ext cx="2916936" cy="274320"/>
+          </a:xfrm>
+          <a:prstGeom prst="rect">
+            <a:avLst/>
+          </a:prstGeom>
+          <a:noFill/>
+        </p:spPr>
+        <p:txBody>
+          <a:bodyPr wrap="square" anchor="t" lIns="0" rIns="0" tIns="0" bIns="0">
+            <a:spAutoFit/>
+          </a:bodyPr>
+          <a:lstStyle/>
+          <a:p>
+            <a:pPr algn="l">
+              <a:lnSpc>
+                <a:spcPct val="100000"/>
+              </a:lnSpc>
+            </a:pPr>
+            <a:r>
+              <a:rPr sz="800" b="0" i="0">
+                <a:solidFill>
+                  <a:srgbClr val="5C6975"/>
+                </a:solidFill>
+                <a:latin typeface="Consolas"/>
+              </a:rPr>
+              <a:t>[ de-identified Emory screening case ]</a:t>
+            </a:r>
+          </a:p>
+        </p:txBody>
+      </p:sp>
+      <p:sp>
+        <p:nvSpPr>
+          <p:cNvPr id="9" name="TextBox 8"/>
+          <p:cNvSpPr txBox="1"/>
+          <p:nvPr/>
+        </p:nvSpPr>
+        <p:spPr>
+          <a:xfrm>
+            <a:off x="4526280" y="868680"/>
+            <a:ext cx="6903720" cy="1051560"/>
+          </a:xfrm>
+          <a:prstGeom prst="rect">
+            <a:avLst/>
+          </a:prstGeom>
+          <a:noFill/>
+        </p:spPr>
+        <p:txBody>
+          <a:bodyPr wrap="square" anchor="t" lIns="0" rIns="0" tIns="0" bIns="0">
+            <a:spAutoFit/>
+          </a:bodyPr>
+          <a:lstStyle/>
+          <a:p>
+            <a:pPr algn="l">
+              <a:lnSpc>
+                <a:spcPct val="112000"/>
+              </a:lnSpc>
+            </a:pPr>
+            <a:r>
+              <a:rPr sz="1900" b="1" i="0">
+                <a:solidFill>
+                  <a:srgbClr val="ECEFF3"/>
+                </a:solidFill>
+                <a:latin typeface="Arial"/>
+              </a:rPr>
+              <a:t>AI reads this </a:t>
+            </a:r>
+            <a:r>
+              <a:rPr sz="1900" b="1" i="0">
+                <a:solidFill>
+                  <a:srgbClr val="E7AC51"/>
+                </a:solidFill>
+                <a:latin typeface="Arial"/>
+              </a:rPr>
+              <a:t>same mammogram</a:t>
+            </a:r>
+            <a:r>
+              <a:rPr sz="1900" b="1" i="0">
+                <a:solidFill>
+                  <a:srgbClr val="ECEFF3"/>
+                </a:solidFill>
+                <a:latin typeface="Arial"/>
+              </a:rPr>
+              <a:t> — and her eventual biopsy slide — for information not visible to us.</a:t>
+            </a:r>
+          </a:p>
+        </p:txBody>
+      </p:sp>
+      <p:sp>
+        <p:nvSpPr>
+          <p:cNvPr id="10" name="Rounded Rectangle 9"/>
+          <p:cNvSpPr/>
+          <p:nvPr/>
+        </p:nvSpPr>
+        <p:spPr>
+          <a:xfrm>
+            <a:off x="4526280" y="2057400"/>
+            <a:ext cx="6903720" cy="914400"/>
+          </a:xfrm>
+          <a:prstGeom prst="roundRect">
+            <a:avLst/>
+          </a:prstGeom>
+          <a:solidFill>
+            <a:srgbClr val="1B232D"/>
+          </a:solidFill>
+          <a:ln w="12700">
+            <a:solidFill>
+              <a:srgbClr val="E7AC51"/>
+            </a:solidFill>
+          </a:ln>
+          <a:effectLst/>
+        </p:spPr>
+        <p:style>
+          <a:lnRef idx="1">
+            <a:schemeClr val="accent1"/>
+          </a:lnRef>
+          <a:fillRef idx="3">
+            <a:schemeClr val="accent1"/>
+          </a:fillRef>
+          <a:effectRef idx="2">
+            <a:schemeClr val="accent1"/>
+          </a:effectRef>
+          <a:fontRef idx="minor">
+            <a:schemeClr val="lt1"/>
+          </a:fontRef>
+        </p:style>
+        <p:txBody>
+          <a:bodyPr rtlCol="0" anchor="ctr" wrap="square" lIns="201168" rIns="164592" tIns="73152" bIns="73152"/>
+          <a:lstStyle/>
+          <a:p>
+            <a:pPr algn="l">
+              <a:lnSpc>
+                <a:spcPct val="112000"/>
+              </a:lnSpc>
+            </a:pPr>
+            <a:r>
+              <a:rPr sz="1100" b="1" i="0">
+                <a:solidFill>
+                  <a:srgbClr val="E7AC51"/>
+                </a:solidFill>
+                <a:latin typeface="Consolas"/>
+              </a:rPr>
+              <a:t>01   </a:t>
+            </a:r>
+            <a:r>
+              <a:rPr sz="1400" b="1" i="0">
+                <a:solidFill>
+                  <a:srgbClr val="5FB7C9"/>
+                </a:solidFill>
+                <a:latin typeface="Arial"/>
+              </a:rPr>
+              <a:t>Image-based risk</a:t>
+            </a:r>
+            <a:r>
+              <a:rPr sz="1400" b="1" i="0">
+                <a:solidFill>
+                  <a:srgbClr val="ECEFF3"/>
+                </a:solidFill>
+                <a:latin typeface="Arial"/>
+              </a:rPr>
+              <a:t> — high probability of cancer within ~5 years</a:t>
+            </a:r>
+          </a:p>
+          <a:p>
+            <a:pPr algn="l">
+              <a:lnSpc>
+                <a:spcPct val="115000"/>
+              </a:lnSpc>
+              <a:spcBef>
+                <a:spcPts val="300"/>
+              </a:spcBef>
+            </a:pPr>
+            <a:r>
+              <a:rPr sz="1100" b="0" i="0">
+                <a:solidFill>
+                  <a:srgbClr val="9DA9B5"/>
+                </a:solidFill>
+                <a:latin typeface="Arial"/>
+              </a:rPr>
+              <a:t>which she developed</a:t>
+            </a:r>
+          </a:p>
+        </p:txBody>
+      </p:sp>
+      <p:sp>
+        <p:nvSpPr>
+          <p:cNvPr id="11" name="Rectangle 10"/>
+          <p:cNvSpPr/>
+          <p:nvPr/>
+        </p:nvSpPr>
+        <p:spPr>
+          <a:xfrm>
+            <a:off x="4526280" y="2057400"/>
+            <a:ext cx="41148" cy="914400"/>
+          </a:xfrm>
+          <a:prstGeom prst="rect">
+            <a:avLst/>
+          </a:prstGeom>
+          <a:solidFill>
+            <a:srgbClr val="E7AC51"/>
+          </a:solidFill>
+          <a:ln>
+            <a:noFill/>
+          </a:ln>
+          <a:effectLst/>
+        </p:spPr>
+        <p:style>
+          <a:lnRef idx="1">
+            <a:schemeClr val="accent1"/>
+          </a:lnRef>
+          <a:fillRef idx="3">
+            <a:schemeClr val="accent1"/>
+          </a:fillRef>
+          <a:effectRef idx="2">
+            <a:schemeClr val="accent1"/>
+          </a:effectRef>
+          <a:fontRef idx="minor">
+            <a:schemeClr val="lt1"/>
+          </a:fontRef>
+        </p:style>
+        <p:txBody>
+          <a:bodyPr rtlCol="0" anchor="ctr"/>
+          <a:lstStyle/>
+          <a:p>
+            <a:pPr algn="ctr"/>
+          </a:p>
+        </p:txBody>
+      </p:sp>
+      <p:sp>
+        <p:nvSpPr>
+          <p:cNvPr id="12" name="Rounded Rectangle 11"/>
+          <p:cNvSpPr/>
+          <p:nvPr/>
+        </p:nvSpPr>
+        <p:spPr>
+          <a:xfrm>
+            <a:off x="4526280" y="3118104"/>
+            <a:ext cx="6903720" cy="914400"/>
+          </a:xfrm>
+          <a:prstGeom prst="roundRect">
+            <a:avLst/>
+          </a:prstGeom>
+          <a:solidFill>
+            <a:srgbClr val="1B232D"/>
+          </a:solidFill>
+          <a:ln w="12700">
+            <a:solidFill>
+              <a:srgbClr val="E7AC51"/>
+            </a:solidFill>
+          </a:ln>
+          <a:effectLst/>
+        </p:spPr>
+        <p:style>
+          <a:lnRef idx="1">
+            <a:schemeClr val="accent1"/>
+          </a:lnRef>
+          <a:fillRef idx="3">
+            <a:schemeClr val="accent1"/>
+          </a:fillRef>
+          <a:effectRef idx="2">
+            <a:schemeClr val="accent1"/>
+          </a:effectRef>
+          <a:fontRef idx="minor">
+            <a:schemeClr val="lt1"/>
+          </a:fontRef>
+        </p:style>
+        <p:txBody>
+          <a:bodyPr rtlCol="0" anchor="ctr" wrap="square" lIns="201168" rIns="164592" tIns="73152" bIns="73152"/>
+          <a:lstStyle/>
+          <a:p>
+            <a:pPr algn="l">
+              <a:lnSpc>
+                <a:spcPct val="112000"/>
+              </a:lnSpc>
+            </a:pPr>
+            <a:r>
+              <a:rPr sz="1100" b="1" i="0">
+                <a:solidFill>
+                  <a:srgbClr val="E7AC51"/>
+                </a:solidFill>
+                <a:latin typeface="Consolas"/>
+              </a:rPr>
+              <a:t>02   </a:t>
+            </a:r>
+            <a:r>
+              <a:rPr sz="1400" b="1" i="0">
+                <a:solidFill>
+                  <a:srgbClr val="5FB7C9"/>
+                </a:solidFill>
+                <a:latin typeface="Arial"/>
+              </a:rPr>
+              <a:t>Cardiovascular disease</a:t>
+            </a:r>
+            <a:r>
+              <a:rPr sz="1400" b="1" i="0">
+                <a:solidFill>
+                  <a:srgbClr val="ECEFF3"/>
+                </a:solidFill>
+                <a:latin typeface="Arial"/>
+              </a:rPr>
+              <a:t> — breast arterial calcification</a:t>
+            </a:r>
+          </a:p>
+          <a:p>
+            <a:pPr algn="l">
+              <a:lnSpc>
+                <a:spcPct val="115000"/>
+              </a:lnSpc>
+              <a:spcBef>
+                <a:spcPts val="300"/>
+              </a:spcBef>
+            </a:pPr>
+            <a:r>
+              <a:rPr sz="1100" b="0" i="0">
+                <a:solidFill>
+                  <a:srgbClr val="9DA9B5"/>
+                </a:solidFill>
+                <a:latin typeface="Arial"/>
+              </a:rPr>
+              <a:t>an independent risk marker, with a dose-response relationship</a:t>
+            </a:r>
+          </a:p>
+        </p:txBody>
+      </p:sp>
+      <p:sp>
+        <p:nvSpPr>
+          <p:cNvPr id="13" name="Rectangle 12"/>
+          <p:cNvSpPr/>
+          <p:nvPr/>
+        </p:nvSpPr>
+        <p:spPr>
+          <a:xfrm>
+            <a:off x="4526280" y="3118104"/>
+            <a:ext cx="41148" cy="914400"/>
+          </a:xfrm>
+          <a:prstGeom prst="rect">
+            <a:avLst/>
+          </a:prstGeom>
+          <a:solidFill>
+            <a:srgbClr val="E7AC51"/>
+          </a:solidFill>
+          <a:ln>
+            <a:noFill/>
+          </a:ln>
+          <a:effectLst/>
+        </p:spPr>
+        <p:style>
+          <a:lnRef idx="1">
+            <a:schemeClr val="accent1"/>
+          </a:lnRef>
+          <a:fillRef idx="3">
+            <a:schemeClr val="accent1"/>
+          </a:fillRef>
+          <a:effectRef idx="2">
+            <a:schemeClr val="accent1"/>
+          </a:effectRef>
+          <a:fontRef idx="minor">
+            <a:schemeClr val="lt1"/>
+          </a:fontRef>
+        </p:style>
+        <p:txBody>
+          <a:bodyPr rtlCol="0" anchor="ctr"/>
+          <a:lstStyle/>
+          <a:p>
+            <a:pPr algn="ctr"/>
+          </a:p>
+        </p:txBody>
+      </p:sp>
+      <p:sp>
+        <p:nvSpPr>
+          <p:cNvPr id="14" name="Rounded Rectangle 13"/>
+          <p:cNvSpPr/>
+          <p:nvPr/>
+        </p:nvSpPr>
+        <p:spPr>
+          <a:xfrm>
+            <a:off x="4526280" y="4178808"/>
+            <a:ext cx="6903720" cy="658368"/>
+          </a:xfrm>
+          <a:prstGeom prst="roundRect">
+            <a:avLst/>
+          </a:prstGeom>
+          <a:solidFill>
+            <a:srgbClr val="1B232D"/>
+          </a:solidFill>
+          <a:ln w="12700">
+            <a:solidFill>
+              <a:srgbClr val="E7AC51"/>
+            </a:solidFill>
+          </a:ln>
+          <a:effectLst/>
+        </p:spPr>
+        <p:style>
+          <a:lnRef idx="1">
+            <a:schemeClr val="accent1"/>
+          </a:lnRef>
+          <a:fillRef idx="3">
+            <a:schemeClr val="accent1"/>
+          </a:fillRef>
+          <a:effectRef idx="2">
+            <a:schemeClr val="accent1"/>
+          </a:effectRef>
+          <a:fontRef idx="minor">
+            <a:schemeClr val="lt1"/>
+          </a:fontRef>
+        </p:style>
+        <p:txBody>
+          <a:bodyPr rtlCol="0" anchor="ctr" wrap="square" lIns="201168" rIns="164592" tIns="73152" bIns="73152"/>
+          <a:lstStyle/>
+          <a:p>
+            <a:pPr algn="l">
+              <a:lnSpc>
+                <a:spcPct val="112000"/>
+              </a:lnSpc>
+            </a:pPr>
+            <a:r>
+              <a:rPr sz="1100" b="1" i="0">
+                <a:solidFill>
+                  <a:srgbClr val="E7AC51"/>
+                </a:solidFill>
+                <a:latin typeface="Consolas"/>
+              </a:rPr>
+              <a:t>03   </a:t>
+            </a:r>
+            <a:r>
+              <a:rPr sz="1400" b="1" i="0">
+                <a:solidFill>
+                  <a:srgbClr val="5FB7C9"/>
+                </a:solidFill>
+                <a:latin typeface="Arial"/>
+              </a:rPr>
+              <a:t>Recurrence prediction</a:t>
+            </a:r>
+            <a:r>
+              <a:rPr sz="1400" b="1" i="0">
+                <a:solidFill>
+                  <a:srgbClr val="ECEFF3"/>
+                </a:solidFill>
+                <a:latin typeface="Arial"/>
+              </a:rPr>
+              <a:t> — a genomic recurrence score from the biopsy slide</a:t>
+            </a:r>
+          </a:p>
+        </p:txBody>
+      </p:sp>
+      <p:sp>
+        <p:nvSpPr>
+          <p:cNvPr id="15" name="Rectangle 14"/>
+          <p:cNvSpPr/>
+          <p:nvPr/>
+        </p:nvSpPr>
+        <p:spPr>
+          <a:xfrm>
+            <a:off x="4526280" y="4178808"/>
+            <a:ext cx="41148" cy="658368"/>
+          </a:xfrm>
+          <a:prstGeom prst="rect">
+            <a:avLst/>
+          </a:prstGeom>
+          <a:solidFill>
+            <a:srgbClr val="E7AC51"/>
+          </a:solidFill>
+          <a:ln>
+            <a:noFill/>
+          </a:ln>
+          <a:effectLst/>
+        </p:spPr>
+        <p:style>
+          <a:lnRef idx="1">
+            <a:schemeClr val="accent1"/>
+          </a:lnRef>
+          <a:fillRef idx="3">
+            <a:schemeClr val="accent1"/>
+          </a:fillRef>
+          <a:effectRef idx="2">
+            <a:schemeClr val="accent1"/>
+          </a:effectRef>
+          <a:fontRef idx="minor">
+            <a:schemeClr val="lt1"/>
+          </a:fontRef>
+        </p:style>
+        <p:txBody>
+          <a:bodyPr rtlCol="0" anchor="ctr"/>
+          <a:lstStyle/>
+          <a:p>
+            <a:pPr algn="ctr"/>
+          </a:p>
+        </p:txBody>
+      </p:sp>
+      <p:sp>
+        <p:nvSpPr>
+          <p:cNvPr id="16" name="TextBox 15"/>
+          <p:cNvSpPr txBox="1"/>
+          <p:nvPr/>
+        </p:nvSpPr>
+        <p:spPr>
+          <a:xfrm>
+            <a:off x="4526280" y="5001768"/>
+            <a:ext cx="6903720" cy="822960"/>
+          </a:xfrm>
+          <a:prstGeom prst="rect">
+            <a:avLst/>
+          </a:prstGeom>
+          <a:noFill/>
+        </p:spPr>
+        <p:txBody>
+          <a:bodyPr wrap="square" anchor="t" lIns="0" rIns="0" tIns="0" bIns="0">
+            <a:spAutoFit/>
+          </a:bodyPr>
+          <a:lstStyle/>
+          <a:p>
+            <a:pPr algn="l">
+              <a:lnSpc>
+                <a:spcPct val="130000"/>
+              </a:lnSpc>
+            </a:pPr>
+            <a:r>
+              <a:rPr sz="1200" b="0" i="0">
+                <a:solidFill>
+                  <a:srgbClr val="9DA9B5"/>
+                </a:solidFill>
+                <a:latin typeface="Arial"/>
+              </a:rPr>
+              <a:t>None of these is hypothetical. Each is published and externally validated — and </a:t>
+            </a:r>
+            <a:r>
+              <a:rPr sz="1200" b="1" i="0">
+                <a:solidFill>
+                  <a:srgbClr val="ECEFF3"/>
+                </a:solidFill>
+                <a:latin typeface="Arial"/>
+              </a:rPr>
+              <a:t>one is already in this year's screening guidelines.</a:t>
+            </a:r>
+          </a:p>
+        </p:txBody>
+      </p:sp>
     </p:spTree>
   </p:cSld>
   <p:clrMapOvr>
@@ -4024,6 +5483,14 @@
 <file path=ppt/slides/slide5.xml><?xml version="1.0" encoding="utf-8"?>
 <p:sld xmlns:a="http://schemas.openxmlformats.org/drawingml/2006/main" xmlns:p="http://schemas.openxmlformats.org/presentationml/2006/main" xmlns:r="http://schemas.openxmlformats.org/officeDocument/2006/relationships">
   <p:cSld>
+    <p:bg>
+      <p:bgPr>
+        <a:solidFill>
+          <a:srgbClr val="0F141A"/>
+        </a:solidFill>
+        <a:effectLst/>
+      </p:bgPr>
+    </p:bg>
     <p:spTree>
       <p:nvGrpSpPr>
         <p:cNvPr id="1" name=""/>
@@ -4031,30 +5498,286 @@
         <p:nvPr/>
       </p:nvGrpSpPr>
       <p:grpSpPr/>
-      <p:pic>
-        <p:nvPicPr>
-          <p:cNvPr id="2" name="Picture 1" descr="hook_04.png"/>
-          <p:cNvPicPr>
-            <a:picLocks noChangeAspect="1"/>
-          </p:cNvPicPr>
+      <p:sp>
+        <p:nvSpPr>
+          <p:cNvPr id="2" name="Rectangle 1"/>
+          <p:cNvSpPr/>
           <p:nvPr/>
-        </p:nvPicPr>
-        <p:blipFill>
-          <a:blip r:embed="rId2"/>
-          <a:stretch>
-            <a:fillRect/>
-          </a:stretch>
-        </p:blipFill>
+        </p:nvSpPr>
         <p:spPr>
           <a:xfrm>
             <a:off x="0" y="0"/>
-            <a:ext cx="12191695" cy="6858000"/>
+            <a:ext cx="5486400" cy="38100"/>
           </a:xfrm>
           <a:prstGeom prst="rect">
             <a:avLst/>
           </a:prstGeom>
-        </p:spPr>
-      </p:pic>
+          <a:solidFill>
+            <a:srgbClr val="E7AC51"/>
+          </a:solidFill>
+          <a:ln>
+            <a:noFill/>
+          </a:ln>
+          <a:effectLst/>
+        </p:spPr>
+        <p:style>
+          <a:lnRef idx="1">
+            <a:schemeClr val="accent1"/>
+          </a:lnRef>
+          <a:fillRef idx="3">
+            <a:schemeClr val="accent1"/>
+          </a:fillRef>
+          <a:effectRef idx="2">
+            <a:schemeClr val="accent1"/>
+          </a:effectRef>
+          <a:fontRef idx="minor">
+            <a:schemeClr val="lt1"/>
+          </a:fontRef>
+        </p:style>
+        <p:txBody>
+          <a:bodyPr rtlCol="0" anchor="ctr"/>
+          <a:lstStyle/>
+          <a:p>
+            <a:pPr algn="ctr"/>
+          </a:p>
+        </p:txBody>
+      </p:sp>
+      <p:sp>
+        <p:nvSpPr>
+          <p:cNvPr id="3" name="TextBox 2"/>
+          <p:cNvSpPr txBox="1"/>
+          <p:nvPr/>
+        </p:nvSpPr>
+        <p:spPr>
+          <a:xfrm>
+            <a:off x="777240" y="1965960"/>
+            <a:ext cx="914400" cy="457200"/>
+          </a:xfrm>
+          <a:prstGeom prst="rect">
+            <a:avLst/>
+          </a:prstGeom>
+          <a:noFill/>
+        </p:spPr>
+        <p:txBody>
+          <a:bodyPr wrap="square" anchor="t" lIns="0" rIns="0" tIns="0" bIns="0">
+            <a:spAutoFit/>
+          </a:bodyPr>
+          <a:lstStyle/>
+          <a:p>
+            <a:pPr algn="l">
+              <a:lnSpc>
+                <a:spcPct val="100000"/>
+              </a:lnSpc>
+            </a:pPr>
+            <a:r>
+              <a:rPr sz="1100" b="0" i="0">
+                <a:solidFill>
+                  <a:srgbClr val="5C6975"/>
+                </a:solidFill>
+                <a:latin typeface="Consolas"/>
+              </a:rPr>
+              <a:t>~30 YRS</a:t>
+            </a:r>
+          </a:p>
+        </p:txBody>
+      </p:sp>
+      <p:sp>
+        <p:nvSpPr>
+          <p:cNvPr id="4" name="TextBox 3"/>
+          <p:cNvSpPr txBox="1"/>
+          <p:nvPr/>
+        </p:nvSpPr>
+        <p:spPr>
+          <a:xfrm>
+            <a:off x="1874519" y="1737360"/>
+            <a:ext cx="9509760" cy="1463040"/>
+          </a:xfrm>
+          <a:prstGeom prst="rect">
+            <a:avLst/>
+          </a:prstGeom>
+          <a:noFill/>
+        </p:spPr>
+        <p:txBody>
+          <a:bodyPr wrap="square" anchor="t" lIns="0" rIns="0" tIns="0" bIns="0">
+            <a:spAutoFit/>
+          </a:bodyPr>
+          <a:lstStyle/>
+          <a:p>
+            <a:pPr algn="l">
+              <a:lnSpc>
+                <a:spcPct val="118000"/>
+              </a:lnSpc>
+            </a:pPr>
+            <a:r>
+              <a:rPr sz="3000" b="1" i="0">
+                <a:solidFill>
+                  <a:srgbClr val="5C6975"/>
+                </a:solidFill>
+                <a:latin typeface="Arial"/>
+              </a:rPr>
+              <a:t>We built tools to </a:t>
+            </a:r>
+            <a:r>
+              <a:rPr sz="3000" b="1" i="0">
+                <a:solidFill>
+                  <a:srgbClr val="5C6975"/>
+                </a:solidFill>
+                <a:latin typeface="Arial"/>
+              </a:rPr>
+              <a:t>find the lesion</a:t>
+            </a:r>
+            <a:r>
+              <a:rPr sz="3000" b="1" i="0">
+                <a:solidFill>
+                  <a:srgbClr val="5C6975"/>
+                </a:solidFill>
+                <a:latin typeface="Arial"/>
+              </a:rPr>
+              <a:t> — to mark the spot. That was CAD.</a:t>
+            </a:r>
+          </a:p>
+        </p:txBody>
+      </p:sp>
+      <p:sp>
+        <p:nvSpPr>
+          <p:cNvPr id="5" name="Rectangle 4"/>
+          <p:cNvSpPr/>
+          <p:nvPr/>
+        </p:nvSpPr>
+        <p:spPr>
+          <a:xfrm>
+            <a:off x="777240" y="3611880"/>
+            <a:ext cx="10607040" cy="12700"/>
+          </a:xfrm>
+          <a:prstGeom prst="rect">
+            <a:avLst/>
+          </a:prstGeom>
+          <a:solidFill>
+            <a:srgbClr val="2A333D"/>
+          </a:solidFill>
+          <a:ln>
+            <a:noFill/>
+          </a:ln>
+          <a:effectLst/>
+        </p:spPr>
+        <p:style>
+          <a:lnRef idx="1">
+            <a:schemeClr val="accent1"/>
+          </a:lnRef>
+          <a:fillRef idx="3">
+            <a:schemeClr val="accent1"/>
+          </a:fillRef>
+          <a:effectRef idx="2">
+            <a:schemeClr val="accent1"/>
+          </a:effectRef>
+          <a:fontRef idx="minor">
+            <a:schemeClr val="lt1"/>
+          </a:fontRef>
+        </p:style>
+        <p:txBody>
+          <a:bodyPr rtlCol="0" anchor="ctr"/>
+          <a:lstStyle/>
+          <a:p>
+            <a:pPr algn="ctr"/>
+          </a:p>
+        </p:txBody>
+      </p:sp>
+      <p:sp>
+        <p:nvSpPr>
+          <p:cNvPr id="6" name="TextBox 5"/>
+          <p:cNvSpPr txBox="1"/>
+          <p:nvPr/>
+        </p:nvSpPr>
+        <p:spPr>
+          <a:xfrm>
+            <a:off x="777240" y="4069080"/>
+            <a:ext cx="914400" cy="457200"/>
+          </a:xfrm>
+          <a:prstGeom prst="rect">
+            <a:avLst/>
+          </a:prstGeom>
+          <a:noFill/>
+        </p:spPr>
+        <p:txBody>
+          <a:bodyPr wrap="square" anchor="t" lIns="0" rIns="0" tIns="0" bIns="0">
+            <a:spAutoFit/>
+          </a:bodyPr>
+          <a:lstStyle/>
+          <a:p>
+            <a:pPr algn="l">
+              <a:lnSpc>
+                <a:spcPct val="100000"/>
+              </a:lnSpc>
+            </a:pPr>
+            <a:r>
+              <a:rPr sz="1100" b="0" i="0">
+                <a:solidFill>
+                  <a:srgbClr val="5C6975"/>
+                </a:solidFill>
+                <a:latin typeface="Consolas"/>
+              </a:rPr>
+              <a:t>NOW</a:t>
+            </a:r>
+          </a:p>
+        </p:txBody>
+      </p:sp>
+      <p:sp>
+        <p:nvSpPr>
+          <p:cNvPr id="7" name="TextBox 6"/>
+          <p:cNvSpPr txBox="1"/>
+          <p:nvPr/>
+        </p:nvSpPr>
+        <p:spPr>
+          <a:xfrm>
+            <a:off x="1874519" y="3886200"/>
+            <a:ext cx="9509760" cy="1463040"/>
+          </a:xfrm>
+          <a:prstGeom prst="rect">
+            <a:avLst/>
+          </a:prstGeom>
+          <a:noFill/>
+        </p:spPr>
+        <p:txBody>
+          <a:bodyPr wrap="square" anchor="t" lIns="0" rIns="0" tIns="0" bIns="0">
+            <a:spAutoFit/>
+          </a:bodyPr>
+          <a:lstStyle/>
+          <a:p>
+            <a:pPr algn="l">
+              <a:lnSpc>
+                <a:spcPct val="118000"/>
+              </a:lnSpc>
+            </a:pPr>
+            <a:r>
+              <a:rPr sz="3000" b="1" i="0">
+                <a:solidFill>
+                  <a:srgbClr val="ECEFF3"/>
+                </a:solidFill>
+                <a:latin typeface="Arial"/>
+              </a:rPr>
+              <a:t>What's changing is the </a:t>
+            </a:r>
+            <a:r>
+              <a:rPr sz="3000" b="1" i="0">
+                <a:solidFill>
+                  <a:srgbClr val="E7AC51"/>
+                </a:solidFill>
+                <a:latin typeface="Arial"/>
+              </a:rPr>
+              <a:t>scope of the question</a:t>
+            </a:r>
+            <a:r>
+              <a:rPr sz="3000" b="1" i="0">
+                <a:solidFill>
+                  <a:srgbClr val="ECEFF3"/>
+                </a:solidFill>
+                <a:latin typeface="Arial"/>
+              </a:rPr>
+              <a:t> we ask.</a:t>
+            </a:r>
+          </a:p>
+        </p:txBody>
+      </p:sp>
     </p:spTree>
   </p:cSld>
   <p:clrMapOvr>
@@ -4066,6 +5789,14 @@
 <file path=ppt/slides/slide6.xml><?xml version="1.0" encoding="utf-8"?>
 <p:sld xmlns:a="http://schemas.openxmlformats.org/drawingml/2006/main" xmlns:p="http://schemas.openxmlformats.org/presentationml/2006/main" xmlns:r="http://schemas.openxmlformats.org/officeDocument/2006/relationships">
   <p:cSld>
+    <p:bg>
+      <p:bgPr>
+        <a:solidFill>
+          <a:srgbClr val="0F141A"/>
+        </a:solidFill>
+        <a:effectLst/>
+      </p:bgPr>
+    </p:bg>
     <p:spTree>
       <p:nvGrpSpPr>
         <p:cNvPr id="1" name=""/>
@@ -4073,30 +5804,759 @@
         <p:nvPr/>
       </p:nvGrpSpPr>
       <p:grpSpPr/>
+      <p:sp>
+        <p:nvSpPr>
+          <p:cNvPr id="2" name="Rectangle 1"/>
+          <p:cNvSpPr/>
+          <p:nvPr/>
+        </p:nvSpPr>
+        <p:spPr>
+          <a:xfrm>
+            <a:off x="0" y="0"/>
+            <a:ext cx="5486400" cy="38100"/>
+          </a:xfrm>
+          <a:prstGeom prst="rect">
+            <a:avLst/>
+          </a:prstGeom>
+          <a:solidFill>
+            <a:srgbClr val="E7AC51"/>
+          </a:solidFill>
+          <a:ln>
+            <a:noFill/>
+          </a:ln>
+          <a:effectLst/>
+        </p:spPr>
+        <p:style>
+          <a:lnRef idx="1">
+            <a:schemeClr val="accent1"/>
+          </a:lnRef>
+          <a:fillRef idx="3">
+            <a:schemeClr val="accent1"/>
+          </a:fillRef>
+          <a:effectRef idx="2">
+            <a:schemeClr val="accent1"/>
+          </a:effectRef>
+          <a:fontRef idx="minor">
+            <a:schemeClr val="lt1"/>
+          </a:fontRef>
+        </p:style>
+        <p:txBody>
+          <a:bodyPr rtlCol="0" anchor="ctr"/>
+          <a:lstStyle/>
+          <a:p>
+            <a:pPr algn="ctr"/>
+          </a:p>
+        </p:txBody>
+      </p:sp>
+      <p:sp>
+        <p:nvSpPr>
+          <p:cNvPr id="3" name="TextBox 2"/>
+          <p:cNvSpPr txBox="1"/>
+          <p:nvPr/>
+        </p:nvSpPr>
+        <p:spPr>
+          <a:xfrm>
+            <a:off x="777240" y="1371600"/>
+            <a:ext cx="10607040" cy="1097280"/>
+          </a:xfrm>
+          <a:prstGeom prst="rect">
+            <a:avLst/>
+          </a:prstGeom>
+          <a:noFill/>
+        </p:spPr>
+        <p:txBody>
+          <a:bodyPr wrap="square" anchor="t" lIns="0" rIns="0" tIns="0" bIns="0">
+            <a:spAutoFit/>
+          </a:bodyPr>
+          <a:lstStyle/>
+          <a:p>
+            <a:pPr algn="l">
+              <a:lnSpc>
+                <a:spcPct val="104000"/>
+              </a:lnSpc>
+            </a:pPr>
+            <a:r>
+              <a:rPr sz="4400" b="1" i="0">
+                <a:solidFill>
+                  <a:srgbClr val="ECEFF3"/>
+                </a:solidFill>
+                <a:latin typeface="Arial"/>
+              </a:rPr>
+              <a:t>From lesions to </a:t>
+            </a:r>
+            <a:r>
+              <a:rPr sz="4400" b="1" i="0">
+                <a:solidFill>
+                  <a:srgbClr val="E7AC51"/>
+                </a:solidFill>
+                <a:latin typeface="Arial"/>
+              </a:rPr>
+              <a:t>patients.</a:t>
+            </a:r>
+          </a:p>
+        </p:txBody>
+      </p:sp>
+      <p:sp>
+        <p:nvSpPr>
+          <p:cNvPr id="4" name="Rounded Rectangle 3"/>
+          <p:cNvSpPr/>
+          <p:nvPr/>
+        </p:nvSpPr>
+        <p:spPr>
+          <a:xfrm>
+            <a:off x="777240" y="3017520"/>
+            <a:ext cx="3429000" cy="2286000"/>
+          </a:xfrm>
+          <a:prstGeom prst="roundRect">
+            <a:avLst/>
+          </a:prstGeom>
+          <a:solidFill>
+            <a:srgbClr val="1B232D"/>
+          </a:solidFill>
+          <a:ln w="15875">
+            <a:solidFill>
+              <a:srgbClr val="2A333D"/>
+            </a:solidFill>
+          </a:ln>
+          <a:effectLst/>
+        </p:spPr>
+        <p:style>
+          <a:lnRef idx="1">
+            <a:schemeClr val="accent1"/>
+          </a:lnRef>
+          <a:fillRef idx="3">
+            <a:schemeClr val="accent1"/>
+          </a:fillRef>
+          <a:effectRef idx="2">
+            <a:schemeClr val="accent1"/>
+          </a:effectRef>
+          <a:fontRef idx="minor">
+            <a:schemeClr val="lt1"/>
+          </a:fontRef>
+        </p:style>
+        <p:txBody>
+          <a:bodyPr rtlCol="0" anchor="t" wrap="square" lIns="256032" rIns="219456" tIns="411480" bIns="182880"/>
+          <a:lstStyle/>
+          <a:p>
+            <a:pPr algn="l">
+              <a:lnSpc>
+                <a:spcPct val="100000"/>
+              </a:lnSpc>
+            </a:pPr>
+            <a:r>
+              <a:rPr sz="1100" b="0" i="0">
+                <a:solidFill>
+                  <a:srgbClr val="5C6975"/>
+                </a:solidFill>
+                <a:latin typeface="Consolas"/>
+              </a:rPr>
+              <a:t>01</a:t>
+            </a:r>
+          </a:p>
+          <a:p>
+            <a:pPr algn="l">
+              <a:lnSpc>
+                <a:spcPct val="100000"/>
+              </a:lnSpc>
+              <a:spcBef>
+                <a:spcPts val="400"/>
+              </a:spcBef>
+            </a:pPr>
+            <a:r>
+              <a:rPr sz="1000" b="1" i="0">
+                <a:solidFill>
+                  <a:srgbClr val="E7AC51"/>
+                </a:solidFill>
+                <a:latin typeface="Consolas"/>
+              </a:rPr>
+              <a:t>PAST</a:t>
+            </a:r>
+          </a:p>
+          <a:p>
+            <a:pPr algn="l">
+              <a:lnSpc>
+                <a:spcPct val="100000"/>
+              </a:lnSpc>
+              <a:spcBef>
+                <a:spcPts val="600"/>
+              </a:spcBef>
+            </a:pPr>
+            <a:r>
+              <a:rPr sz="2600" b="1" i="0">
+                <a:solidFill>
+                  <a:srgbClr val="ECEFF3"/>
+                </a:solidFill>
+                <a:latin typeface="Arial"/>
+              </a:rPr>
+              <a:t>Lesion</a:t>
+            </a:r>
+          </a:p>
+          <a:p>
+            <a:pPr algn="l">
+              <a:lnSpc>
+                <a:spcPct val="125000"/>
+              </a:lnSpc>
+              <a:spcBef>
+                <a:spcPts val="600"/>
+              </a:spcBef>
+            </a:pPr>
+            <a:r>
+              <a:rPr sz="1250" b="0" i="0">
+                <a:solidFill>
+                  <a:srgbClr val="9DA9B5"/>
+                </a:solidFill>
+                <a:latin typeface="Arial"/>
+              </a:rPr>
+              <a:t>find &amp; characterize</a:t>
+            </a:r>
+          </a:p>
+        </p:txBody>
+      </p:sp>
+      <p:sp>
+        <p:nvSpPr>
+          <p:cNvPr id="5" name="Rectangle 4"/>
+          <p:cNvSpPr/>
+          <p:nvPr/>
+        </p:nvSpPr>
+        <p:spPr>
+          <a:xfrm>
+            <a:off x="1005840" y="3218688"/>
+            <a:ext cx="411480" cy="32004"/>
+          </a:xfrm>
+          <a:prstGeom prst="rect">
+            <a:avLst/>
+          </a:prstGeom>
+          <a:solidFill>
+            <a:srgbClr val="E7AC51"/>
+          </a:solidFill>
+          <a:ln>
+            <a:noFill/>
+          </a:ln>
+          <a:effectLst/>
+        </p:spPr>
+        <p:style>
+          <a:lnRef idx="1">
+            <a:schemeClr val="accent1"/>
+          </a:lnRef>
+          <a:fillRef idx="3">
+            <a:schemeClr val="accent1"/>
+          </a:fillRef>
+          <a:effectRef idx="2">
+            <a:schemeClr val="accent1"/>
+          </a:effectRef>
+          <a:fontRef idx="minor">
+            <a:schemeClr val="lt1"/>
+          </a:fontRef>
+        </p:style>
+        <p:txBody>
+          <a:bodyPr rtlCol="0" anchor="ctr"/>
+          <a:lstStyle/>
+          <a:p>
+            <a:pPr algn="ctr"/>
+          </a:p>
+        </p:txBody>
+      </p:sp>
+      <p:sp>
+        <p:nvSpPr>
+          <p:cNvPr id="6" name="Rounded Rectangle 5"/>
+          <p:cNvSpPr/>
+          <p:nvPr/>
+        </p:nvSpPr>
+        <p:spPr>
+          <a:xfrm>
+            <a:off x="4457700" y="3017520"/>
+            <a:ext cx="3429000" cy="2286000"/>
+          </a:xfrm>
+          <a:prstGeom prst="roundRect">
+            <a:avLst/>
+          </a:prstGeom>
+          <a:solidFill>
+            <a:srgbClr val="3A2E16"/>
+          </a:solidFill>
+          <a:ln w="15875">
+            <a:solidFill>
+              <a:srgbClr val="C98A2E"/>
+            </a:solidFill>
+          </a:ln>
+          <a:effectLst/>
+        </p:spPr>
+        <p:style>
+          <a:lnRef idx="1">
+            <a:schemeClr val="accent1"/>
+          </a:lnRef>
+          <a:fillRef idx="3">
+            <a:schemeClr val="accent1"/>
+          </a:fillRef>
+          <a:effectRef idx="2">
+            <a:schemeClr val="accent1"/>
+          </a:effectRef>
+          <a:fontRef idx="minor">
+            <a:schemeClr val="lt1"/>
+          </a:fontRef>
+        </p:style>
+        <p:txBody>
+          <a:bodyPr rtlCol="0" anchor="t" wrap="square" lIns="256032" rIns="219456" tIns="411480" bIns="182880"/>
+          <a:lstStyle/>
+          <a:p>
+            <a:pPr algn="l">
+              <a:lnSpc>
+                <a:spcPct val="100000"/>
+              </a:lnSpc>
+            </a:pPr>
+            <a:r>
+              <a:rPr sz="1100" b="0" i="0">
+                <a:solidFill>
+                  <a:srgbClr val="5C6975"/>
+                </a:solidFill>
+                <a:latin typeface="Consolas"/>
+              </a:rPr>
+              <a:t>02</a:t>
+            </a:r>
+          </a:p>
+          <a:p>
+            <a:pPr algn="l">
+              <a:lnSpc>
+                <a:spcPct val="100000"/>
+              </a:lnSpc>
+              <a:spcBef>
+                <a:spcPts val="400"/>
+              </a:spcBef>
+            </a:pPr>
+            <a:r>
+              <a:rPr sz="1000" b="1" i="0">
+                <a:solidFill>
+                  <a:srgbClr val="E7AC51"/>
+                </a:solidFill>
+                <a:latin typeface="Consolas"/>
+              </a:rPr>
+              <a:t>PRESENT</a:t>
+            </a:r>
+          </a:p>
+          <a:p>
+            <a:pPr algn="l">
+              <a:lnSpc>
+                <a:spcPct val="100000"/>
+              </a:lnSpc>
+              <a:spcBef>
+                <a:spcPts val="600"/>
+              </a:spcBef>
+            </a:pPr>
+            <a:r>
+              <a:rPr sz="2600" b="1" i="0">
+                <a:solidFill>
+                  <a:srgbClr val="ECEFF3"/>
+                </a:solidFill>
+                <a:latin typeface="Arial"/>
+              </a:rPr>
+              <a:t>Image</a:t>
+            </a:r>
+          </a:p>
+          <a:p>
+            <a:pPr algn="l">
+              <a:lnSpc>
+                <a:spcPct val="125000"/>
+              </a:lnSpc>
+              <a:spcBef>
+                <a:spcPts val="600"/>
+              </a:spcBef>
+            </a:pPr>
+            <a:r>
+              <a:rPr sz="1250" b="0" i="0">
+                <a:solidFill>
+                  <a:srgbClr val="9DA9B5"/>
+                </a:solidFill>
+                <a:latin typeface="Arial"/>
+              </a:rPr>
+              <a:t>risk &amp; opportunistic signal</a:t>
+            </a:r>
+          </a:p>
+        </p:txBody>
+      </p:sp>
+      <p:sp>
+        <p:nvSpPr>
+          <p:cNvPr id="7" name="Rectangle 6"/>
+          <p:cNvSpPr/>
+          <p:nvPr/>
+        </p:nvSpPr>
+        <p:spPr>
+          <a:xfrm>
+            <a:off x="4686300" y="3218688"/>
+            <a:ext cx="411480" cy="32004"/>
+          </a:xfrm>
+          <a:prstGeom prst="rect">
+            <a:avLst/>
+          </a:prstGeom>
+          <a:solidFill>
+            <a:srgbClr val="E7AC51"/>
+          </a:solidFill>
+          <a:ln>
+            <a:noFill/>
+          </a:ln>
+          <a:effectLst/>
+        </p:spPr>
+        <p:style>
+          <a:lnRef idx="1">
+            <a:schemeClr val="accent1"/>
+          </a:lnRef>
+          <a:fillRef idx="3">
+            <a:schemeClr val="accent1"/>
+          </a:fillRef>
+          <a:effectRef idx="2">
+            <a:schemeClr val="accent1"/>
+          </a:effectRef>
+          <a:fontRef idx="minor">
+            <a:schemeClr val="lt1"/>
+          </a:fontRef>
+        </p:style>
+        <p:txBody>
+          <a:bodyPr rtlCol="0" anchor="ctr"/>
+          <a:lstStyle/>
+          <a:p>
+            <a:pPr algn="ctr"/>
+          </a:p>
+        </p:txBody>
+      </p:sp>
+      <p:sp>
+        <p:nvSpPr>
+          <p:cNvPr id="8" name="Rounded Rectangle 7"/>
+          <p:cNvSpPr/>
+          <p:nvPr/>
+        </p:nvSpPr>
+        <p:spPr>
+          <a:xfrm>
+            <a:off x="8138160" y="3017520"/>
+            <a:ext cx="3429000" cy="2286000"/>
+          </a:xfrm>
+          <a:prstGeom prst="roundRect">
+            <a:avLst/>
+          </a:prstGeom>
+          <a:solidFill>
+            <a:srgbClr val="E7AC51"/>
+          </a:solidFill>
+          <a:ln w="15875">
+            <a:solidFill>
+              <a:srgbClr val="C98A2E"/>
+            </a:solidFill>
+          </a:ln>
+          <a:effectLst/>
+        </p:spPr>
+        <p:style>
+          <a:lnRef idx="1">
+            <a:schemeClr val="accent1"/>
+          </a:lnRef>
+          <a:fillRef idx="3">
+            <a:schemeClr val="accent1"/>
+          </a:fillRef>
+          <a:effectRef idx="2">
+            <a:schemeClr val="accent1"/>
+          </a:effectRef>
+          <a:fontRef idx="minor">
+            <a:schemeClr val="lt1"/>
+          </a:fontRef>
+        </p:style>
+        <p:txBody>
+          <a:bodyPr rtlCol="0" anchor="t" wrap="square" lIns="256032" rIns="219456" tIns="411480" bIns="182880"/>
+          <a:lstStyle/>
+          <a:p>
+            <a:pPr algn="l">
+              <a:lnSpc>
+                <a:spcPct val="100000"/>
+              </a:lnSpc>
+            </a:pPr>
+            <a:r>
+              <a:rPr sz="1100" b="0" i="0">
+                <a:solidFill>
+                  <a:srgbClr val="403014"/>
+                </a:solidFill>
+                <a:latin typeface="Consolas"/>
+              </a:rPr>
+              <a:t>03</a:t>
+            </a:r>
+          </a:p>
+          <a:p>
+            <a:pPr algn="l">
+              <a:lnSpc>
+                <a:spcPct val="100000"/>
+              </a:lnSpc>
+              <a:spcBef>
+                <a:spcPts val="400"/>
+              </a:spcBef>
+            </a:pPr>
+            <a:r>
+              <a:rPr sz="1000" b="1" i="0">
+                <a:solidFill>
+                  <a:srgbClr val="1A1206"/>
+                </a:solidFill>
+                <a:latin typeface="Consolas"/>
+              </a:rPr>
+              <a:t>FUTURE</a:t>
+            </a:r>
+          </a:p>
+          <a:p>
+            <a:pPr algn="l">
+              <a:lnSpc>
+                <a:spcPct val="100000"/>
+              </a:lnSpc>
+              <a:spcBef>
+                <a:spcPts val="600"/>
+              </a:spcBef>
+            </a:pPr>
+            <a:r>
+              <a:rPr sz="2600" b="1" i="0">
+                <a:solidFill>
+                  <a:srgbClr val="1A1206"/>
+                </a:solidFill>
+                <a:latin typeface="Arial"/>
+              </a:rPr>
+              <a:t>Patient</a:t>
+            </a:r>
+          </a:p>
+          <a:p>
+            <a:pPr algn="l">
+              <a:lnSpc>
+                <a:spcPct val="125000"/>
+              </a:lnSpc>
+              <a:spcBef>
+                <a:spcPts val="600"/>
+              </a:spcBef>
+            </a:pPr>
+            <a:r>
+              <a:rPr sz="1250" b="0" i="0">
+                <a:solidFill>
+                  <a:srgbClr val="2A1E0A"/>
+                </a:solidFill>
+                <a:latin typeface="Arial"/>
+              </a:rPr>
+              <a:t>pathology + integration</a:t>
+            </a:r>
+          </a:p>
+        </p:txBody>
+      </p:sp>
+      <p:sp>
+        <p:nvSpPr>
+          <p:cNvPr id="9" name="Rectangle 8"/>
+          <p:cNvSpPr/>
+          <p:nvPr/>
+        </p:nvSpPr>
+        <p:spPr>
+          <a:xfrm>
+            <a:off x="8366760" y="3218688"/>
+            <a:ext cx="411480" cy="32004"/>
+          </a:xfrm>
+          <a:prstGeom prst="rect">
+            <a:avLst/>
+          </a:prstGeom>
+          <a:solidFill>
+            <a:srgbClr val="000000"/>
+          </a:solidFill>
+          <a:ln>
+            <a:noFill/>
+          </a:ln>
+          <a:effectLst/>
+        </p:spPr>
+        <p:style>
+          <a:lnRef idx="1">
+            <a:schemeClr val="accent1"/>
+          </a:lnRef>
+          <a:fillRef idx="3">
+            <a:schemeClr val="accent1"/>
+          </a:fillRef>
+          <a:effectRef idx="2">
+            <a:schemeClr val="accent1"/>
+          </a:effectRef>
+          <a:fontRef idx="minor">
+            <a:schemeClr val="lt1"/>
+          </a:fontRef>
+        </p:style>
+        <p:txBody>
+          <a:bodyPr rtlCol="0" anchor="ctr"/>
+          <a:lstStyle/>
+          <a:p>
+            <a:pPr algn="ctr"/>
+          </a:p>
+        </p:txBody>
+      </p:sp>
+    </p:spTree>
+  </p:cSld>
+  <p:clrMapOvr>
+    <a:masterClrMapping/>
+  </p:clrMapOvr>
+</p:sld>
+</file>
+
+<file path=ppt/slides/slide7.xml><?xml version="1.0" encoding="utf-8"?>
+<p:sld xmlns:a="http://schemas.openxmlformats.org/drawingml/2006/main" xmlns:p="http://schemas.openxmlformats.org/presentationml/2006/main" xmlns:r="http://schemas.openxmlformats.org/officeDocument/2006/relationships">
+  <p:cSld>
+    <p:bg>
+      <p:bgPr>
+        <a:solidFill>
+          <a:srgbClr val="0F141A"/>
+        </a:solidFill>
+        <a:effectLst/>
+      </p:bgPr>
+    </p:bg>
+    <p:spTree>
+      <p:nvGrpSpPr>
+        <p:cNvPr id="1" name=""/>
+        <p:cNvGrpSpPr/>
+        <p:nvPr/>
+      </p:nvGrpSpPr>
+      <p:grpSpPr/>
+      <p:sp>
+        <p:nvSpPr>
+          <p:cNvPr id="2" name="Rectangle 1"/>
+          <p:cNvSpPr/>
+          <p:nvPr/>
+        </p:nvSpPr>
+        <p:spPr>
+          <a:xfrm>
+            <a:off x="0" y="0"/>
+            <a:ext cx="5486400" cy="38100"/>
+          </a:xfrm>
+          <a:prstGeom prst="rect">
+            <a:avLst/>
+          </a:prstGeom>
+          <a:solidFill>
+            <a:srgbClr val="E7AC51"/>
+          </a:solidFill>
+          <a:ln>
+            <a:noFill/>
+          </a:ln>
+          <a:effectLst/>
+        </p:spPr>
+        <p:style>
+          <a:lnRef idx="1">
+            <a:schemeClr val="accent1"/>
+          </a:lnRef>
+          <a:fillRef idx="3">
+            <a:schemeClr val="accent1"/>
+          </a:fillRef>
+          <a:effectRef idx="2">
+            <a:schemeClr val="accent1"/>
+          </a:effectRef>
+          <a:fontRef idx="minor">
+            <a:schemeClr val="lt1"/>
+          </a:fontRef>
+        </p:style>
+        <p:txBody>
+          <a:bodyPr rtlCol="0" anchor="ctr"/>
+          <a:lstStyle/>
+          <a:p>
+            <a:pPr algn="ctr"/>
+          </a:p>
+        </p:txBody>
+      </p:sp>
+      <p:sp>
+        <p:nvSpPr>
+          <p:cNvPr id="3" name="TextBox 2"/>
+          <p:cNvSpPr txBox="1"/>
+          <p:nvPr/>
+        </p:nvSpPr>
+        <p:spPr>
+          <a:xfrm>
+            <a:off x="914400" y="1143000"/>
+            <a:ext cx="10332720" cy="1005840"/>
+          </a:xfrm>
+          <a:prstGeom prst="rect">
+            <a:avLst/>
+          </a:prstGeom>
+          <a:noFill/>
+        </p:spPr>
+        <p:txBody>
+          <a:bodyPr wrap="square" anchor="t" lIns="0" rIns="0" tIns="0" bIns="0">
+            <a:spAutoFit/>
+          </a:bodyPr>
+          <a:lstStyle/>
+          <a:p>
+            <a:pPr algn="ctr">
+              <a:lnSpc>
+                <a:spcPct val="100000"/>
+              </a:lnSpc>
+            </a:pPr>
+            <a:r>
+              <a:rPr sz="4000" b="1" i="0">
+                <a:solidFill>
+                  <a:srgbClr val="ECEFF3"/>
+                </a:solidFill>
+                <a:latin typeface="Arial"/>
+              </a:rPr>
+              <a:t>Let's step into a </a:t>
+            </a:r>
+            <a:r>
+              <a:rPr sz="4000" b="1" i="0">
+                <a:solidFill>
+                  <a:srgbClr val="E7AC51"/>
+                </a:solidFill>
+                <a:latin typeface="Arial"/>
+              </a:rPr>
+              <a:t>time machine.</a:t>
+            </a:r>
+          </a:p>
+        </p:txBody>
+      </p:sp>
       <p:pic>
         <p:nvPicPr>
-          <p:cNvPr id="2" name="Picture 1" descr="hook_05.png"/>
+          <p:cNvPr id="4" name="Picture 3" descr="svg_9646a542a0.png"/>
           <p:cNvPicPr>
             <a:picLocks noChangeAspect="1"/>
           </p:cNvPicPr>
           <p:nvPr/>
         </p:nvPicPr>
         <p:blipFill>
-          <a:blip r:embed="rId2"/>
+          <a:blip r:embed="rId3"/>
           <a:stretch>
             <a:fillRect/>
           </a:stretch>
         </p:blipFill>
         <p:spPr>
           <a:xfrm>
-            <a:off x="0" y="0"/>
-            <a:ext cx="12191695" cy="6858000"/>
+            <a:off x="3794760" y="2717074"/>
+            <a:ext cx="4572000" cy="2612571"/>
           </a:xfrm>
           <a:prstGeom prst="rect">
             <a:avLst/>
           </a:prstGeom>
         </p:spPr>
       </p:pic>
+      <p:sp>
+        <p:nvSpPr>
+          <p:cNvPr id="5" name="TextBox 4"/>
+          <p:cNvSpPr txBox="1"/>
+          <p:nvPr/>
+        </p:nvSpPr>
+        <p:spPr>
+          <a:xfrm>
+            <a:off x="914400" y="5989320"/>
+            <a:ext cx="10332720" cy="457200"/>
+          </a:xfrm>
+          <a:prstGeom prst="rect">
+            <a:avLst/>
+          </a:prstGeom>
+          <a:noFill/>
+        </p:spPr>
+        <p:txBody>
+          <a:bodyPr wrap="square" anchor="t" lIns="0" rIns="0" tIns="0" bIns="0">
+            <a:spAutoFit/>
+          </a:bodyPr>
+          <a:lstStyle/>
+          <a:p>
+            <a:pPr algn="ctr">
+              <a:lnSpc>
+                <a:spcPct val="100000"/>
+              </a:lnSpc>
+            </a:pPr>
+            <a:r>
+              <a:rPr sz="1400" b="0" i="0">
+                <a:solidFill>
+                  <a:srgbClr val="9DA9B5"/>
+                </a:solidFill>
+                <a:latin typeface="Arial"/>
+              </a:rPr>
+              <a:t>This field has overpromised before. Let's start there — in 1998.</a:t>
+            </a:r>
+          </a:p>
+        </p:txBody>
+      </p:sp>
     </p:spTree>
   </p:cSld>
   <p:clrMapOvr>

</xml_diff>